<commit_message>
Correct day 2: the Apgar shuttle is express to Logan Pass
I had the west-side shuttle wrong. It runs direct from the Apgar
Visitor Center to Logan Pass with no intermediate stops — there is no
transfer at Avalanche Creek, in either direction.

The two outbound legs collapse into one express ride, and the return
leg no longer claims a second transfer; the summit group picks up the
westbound shuttle at The Loop, the lakes group at Logan Pass. Same
correction applied to the deck's day 2 slide and its logistics row,
where the transport chain loses its now-imaginary middle hop.

No mention of a transfer left anywhere in the sheets or the deck.

Co-Authored-By: Claude Opus 5 <noreply@anthropic.com>
Claude-Session: https://claude.ai/code/session_01ETBxG2Bscni8WhEqaPd6vD
</commit_message>
<xml_diff>
--- a/hikes/slides/glacier-hikes.pptx
+++ b/hikes/slides/glacier-hikes.pptx
@@ -5682,7 +5682,7 @@
                 <a:ea typeface="Arial" pitchFamily="34" charset="-122"/>
                 <a:cs typeface="Arial" pitchFamily="34" charset="-120"/>
               </a:rPr>
-              <a:t>Bus from Apgar</a:t>
+              <a:t>Express shuttle to Logan Pass</a:t>
             </a:r>
             <a:pPr indent="0" marL="0">
               <a:buNone/>
@@ -5696,7 +5696,7 @@
                 <a:ea typeface="Arial" pitchFamily="34" charset="-122"/>
                 <a:cs typeface="Arial" pitchFamily="34" charset="-120"/>
               </a:rPr>
-              <a:t>, transferring at Avalanche Creek.</a:t>
+              <a:t> — direct, no stops on the way up.</a:t>
             </a:r>
             <a:endParaRPr lang="en-US" sz="1150" dirty="0"/>
           </a:p>
@@ -5794,7 +5794,7 @@
                 <a:ea typeface="Arial" pitchFamily="34" charset="-122"/>
                 <a:cs typeface="Arial" pitchFamily="34" charset="-120"/>
               </a:rPr>
-              <a:t>Shuttle to Logan Pass</a:t>
+              <a:t>Both groups get off there</a:t>
             </a:r>
             <a:pPr indent="0" marL="0">
               <a:buNone/>
@@ -5808,7 +5808,7 @@
                 <a:ea typeface="Arial" pitchFamily="34" charset="-122"/>
                 <a:cs typeface="Arial" pitchFamily="34" charset="-120"/>
               </a:rPr>
-              <a:t> — both groups start here and split.</a:t>
+              <a:t> and split at the visitor center.</a:t>
             </a:r>
             <a:endParaRPr lang="en-US" sz="1150" dirty="0"/>
           </a:p>
@@ -5906,7 +5906,7 @@
                 <a:ea typeface="Arial" pitchFamily="34" charset="-122"/>
                 <a:cs typeface="Arial" pitchFamily="34" charset="-120"/>
               </a:rPr>
-              <a:t>Shuttle back</a:t>
+              <a:t>Westbound shuttle back</a:t>
             </a:r>
             <a:pPr indent="0" marL="0">
               <a:buNone/>
@@ -7655,7 +7655,7 @@
         <p:spPr>
           <a:xfrm>
             <a:off x="6166714" y="3630168"/>
-            <a:ext cx="479146" cy="347472"/>
+            <a:ext cx="2571293" cy="347472"/>
           </a:xfrm>
           <a:prstGeom prst="roundRect">
             <a:avLst>
@@ -7677,7 +7677,7 @@
         <p:spPr>
           <a:xfrm>
             <a:off x="6166714" y="3630168"/>
-            <a:ext cx="479146" cy="347472"/>
+            <a:ext cx="2571293" cy="347472"/>
           </a:xfrm>
           <a:prstGeom prst="rect">
             <a:avLst/>
@@ -7701,7 +7701,7 @@
                 <a:ea typeface="Arial" pitchFamily="34" charset="-122"/>
                 <a:cs typeface="Arial" pitchFamily="34" charset="-120"/>
               </a:rPr>
-              <a:t>Bus</a:t>
+              <a:t>Express shuttle to Logan Pass</a:t>
             </a:r>
             <a:endParaRPr lang="en-US" sz="1000" dirty="0"/>
           </a:p>
@@ -7715,7 +7715,7 @@
         </p:nvSpPr>
         <p:spPr>
           <a:xfrm>
-            <a:off x="6645859" y="3630168"/>
+            <a:off x="8738006" y="3630168"/>
             <a:ext cx="219456" cy="347472"/>
           </a:xfrm>
           <a:prstGeom prst="rect">
@@ -7754,8 +7754,8 @@
         </p:nvSpPr>
         <p:spPr>
           <a:xfrm>
-            <a:off x="6865315" y="3630168"/>
-            <a:ext cx="1927555" cy="347472"/>
+            <a:off x="8957462" y="3630168"/>
+            <a:ext cx="559613" cy="347472"/>
           </a:xfrm>
           <a:prstGeom prst="roundRect">
             <a:avLst>
@@ -7763,7 +7763,7 @@
             </a:avLst>
           </a:prstGeom>
           <a:solidFill>
-            <a:srgbClr val="3D6EA5"/>
+            <a:srgbClr val="E2574C"/>
           </a:solidFill>
           <a:ln/>
         </p:spPr>
@@ -7776,8 +7776,8 @@
         </p:nvSpPr>
         <p:spPr>
           <a:xfrm>
-            <a:off x="6865315" y="3630168"/>
-            <a:ext cx="1927555" cy="347472"/>
+            <a:off x="8957462" y="3630168"/>
+            <a:ext cx="559613" cy="347472"/>
           </a:xfrm>
           <a:prstGeom prst="rect">
             <a:avLst/>
@@ -7801,7 +7801,7 @@
                 <a:ea typeface="Arial" pitchFamily="34" charset="-122"/>
                 <a:cs typeface="Arial" pitchFamily="34" charset="-120"/>
               </a:rPr>
-              <a:t>Shuttle to Logan Pass</a:t>
+              <a:t>Hike</a:t>
             </a:r>
             <a:endParaRPr lang="en-US" sz="1000" dirty="0"/>
           </a:p>
@@ -7815,7 +7815,7 @@
         </p:nvSpPr>
         <p:spPr>
           <a:xfrm>
-            <a:off x="8792870" y="3630168"/>
+            <a:off x="9517075" y="3630168"/>
             <a:ext cx="219456" cy="347472"/>
           </a:xfrm>
           <a:prstGeom prst="rect">
@@ -7854,8 +7854,8 @@
         </p:nvSpPr>
         <p:spPr>
           <a:xfrm>
-            <a:off x="9012326" y="3630168"/>
-            <a:ext cx="559613" cy="347472"/>
+            <a:off x="9736531" y="3630168"/>
+            <a:ext cx="1203350" cy="347472"/>
           </a:xfrm>
           <a:prstGeom prst="roundRect">
             <a:avLst>
@@ -7863,6 +7863,129 @@
             </a:avLst>
           </a:prstGeom>
           <a:solidFill>
+            <a:srgbClr val="3D6EA5"/>
+          </a:solidFill>
+          <a:ln/>
+        </p:spPr>
+      </p:sp>
+      <p:sp>
+        <p:nvSpPr>
+          <p:cNvPr id="31" name="Text 29"/>
+          <p:cNvSpPr/>
+          <p:nvPr/>
+        </p:nvSpPr>
+        <p:spPr>
+          <a:xfrm>
+            <a:off x="9736531" y="3630168"/>
+            <a:ext cx="1203350" cy="347472"/>
+          </a:xfrm>
+          <a:prstGeom prst="rect">
+            <a:avLst/>
+          </a:prstGeom>
+          <a:noFill/>
+          <a:ln/>
+        </p:spPr>
+        <p:txBody>
+          <a:bodyPr wrap="square" lIns="0" tIns="0" rIns="0" bIns="0" rtlCol="0" anchor="ctr"/>
+          <a:lstStyle/>
+          <a:p>
+            <a:pPr algn="ctr" indent="0" marL="0">
+              <a:buNone/>
+            </a:pPr>
+            <a:r>
+              <a:rPr lang="en-US" sz="1000" b="1" dirty="0">
+                <a:solidFill>
+                  <a:srgbClr val="FFFFFF"/>
+                </a:solidFill>
+                <a:latin typeface="Arial" pitchFamily="34" charset="0"/>
+                <a:ea typeface="Arial" pitchFamily="34" charset="-122"/>
+                <a:cs typeface="Arial" pitchFamily="34" charset="-120"/>
+              </a:rPr>
+              <a:t>Shuttle back</a:t>
+            </a:r>
+            <a:endParaRPr lang="en-US" sz="1000" dirty="0"/>
+          </a:p>
+        </p:txBody>
+      </p:sp>
+      <p:sp>
+        <p:nvSpPr>
+          <p:cNvPr id="32" name="Text 30"/>
+          <p:cNvSpPr/>
+          <p:nvPr/>
+        </p:nvSpPr>
+        <p:spPr>
+          <a:xfrm>
+            <a:off x="1371600" y="4105656"/>
+            <a:ext cx="9997135" cy="512064"/>
+          </a:xfrm>
+          <a:prstGeom prst="rect">
+            <a:avLst/>
+          </a:prstGeom>
+          <a:noFill/>
+          <a:ln/>
+        </p:spPr>
+        <p:txBody>
+          <a:bodyPr wrap="square" lIns="0" tIns="0" rIns="0" bIns="0" rtlCol="0" anchor="t"/>
+          <a:lstStyle/>
+          <a:p>
+            <a:pPr indent="0" marL="0">
+              <a:lnSpc>
+                <a:spcPts val="1500"/>
+              </a:lnSpc>
+              <a:buNone/>
+            </a:pPr>
+            <a:r>
+              <a:rPr lang="en-US" sz="1150" dirty="0">
+                <a:solidFill>
+                  <a:srgbClr val="A9A296"/>
+                </a:solidFill>
+                <a:latin typeface="Arial" pitchFamily="34" charset="0"/>
+                <a:ea typeface="Arial" pitchFamily="34" charset="-122"/>
+                <a:cs typeface="Arial" pitchFamily="34" charset="-120"/>
+              </a:rPr>
+              <a:t>The Apgar shuttle runs express to Logan Pass, no stops on the way up. We should be long gone by then, but the last bus out of The Loop is 7:30 pm and the summit group has to be down before it goes.</a:t>
+            </a:r>
+            <a:endParaRPr lang="en-US" sz="1150" dirty="0"/>
+          </a:p>
+        </p:txBody>
+      </p:sp>
+      <p:sp>
+        <p:nvSpPr>
+          <p:cNvPr id="33" name="Shape 31"/>
+          <p:cNvSpPr/>
+          <p:nvPr/>
+        </p:nvSpPr>
+        <p:spPr>
+          <a:xfrm>
+            <a:off x="640080" y="4928616"/>
+            <a:ext cx="10911535" cy="1426464"/>
+          </a:xfrm>
+          <a:prstGeom prst="roundRect">
+            <a:avLst>
+              <a:gd name="adj" fmla="val 3205"/>
+            </a:avLst>
+          </a:prstGeom>
+          <a:solidFill>
+            <a:srgbClr val="2E2B27"/>
+          </a:solidFill>
+          <a:ln/>
+        </p:spPr>
+      </p:sp>
+      <p:sp>
+        <p:nvSpPr>
+          <p:cNvPr id="34" name="Shape 32"/>
+          <p:cNvSpPr/>
+          <p:nvPr/>
+        </p:nvSpPr>
+        <p:spPr>
+          <a:xfrm>
+            <a:off x="914400" y="5202936"/>
+            <a:ext cx="347472" cy="347472"/>
+          </a:xfrm>
+          <a:prstGeom prst="ellipse">
+            <a:avLst/>
+          </a:prstGeom>
+          <a:solidFill>
             <a:srgbClr val="E2574C"/>
           </a:solidFill>
           <a:ln/>
@@ -7870,14 +7993,14 @@
       </p:sp>
       <p:sp>
         <p:nvSpPr>
-          <p:cNvPr id="31" name="Text 29"/>
-          <p:cNvSpPr/>
-          <p:nvPr/>
-        </p:nvSpPr>
-        <p:spPr>
-          <a:xfrm>
-            <a:off x="9012326" y="3630168"/>
-            <a:ext cx="559613" cy="347472"/>
+          <p:cNvPr id="35" name="Text 33"/>
+          <p:cNvSpPr/>
+          <p:nvPr/>
+        </p:nvSpPr>
+        <p:spPr>
+          <a:xfrm>
+            <a:off x="914400" y="5202936"/>
+            <a:ext cx="347472" cy="347472"/>
           </a:xfrm>
           <a:prstGeom prst="rect">
             <a:avLst/>
@@ -7893,7 +8016,7 @@
               <a:buNone/>
             </a:pPr>
             <a:r>
-              <a:rPr lang="en-US" sz="1000" b="1" dirty="0">
+              <a:rPr lang="en-US" sz="1300" b="1" dirty="0">
                 <a:solidFill>
                   <a:srgbClr val="FFFFFF"/>
                 </a:solidFill>
@@ -7901,46 +8024,7 @@
                 <a:ea typeface="Arial" pitchFamily="34" charset="-122"/>
                 <a:cs typeface="Arial" pitchFamily="34" charset="-120"/>
               </a:rPr>
-              <a:t>Hike</a:t>
-            </a:r>
-            <a:endParaRPr lang="en-US" sz="1000" dirty="0"/>
-          </a:p>
-        </p:txBody>
-      </p:sp>
-      <p:sp>
-        <p:nvSpPr>
-          <p:cNvPr id="32" name="Text 30"/>
-          <p:cNvSpPr/>
-          <p:nvPr/>
-        </p:nvSpPr>
-        <p:spPr>
-          <a:xfrm>
-            <a:off x="9571939" y="3630168"/>
-            <a:ext cx="219456" cy="347472"/>
-          </a:xfrm>
-          <a:prstGeom prst="rect">
-            <a:avLst/>
-          </a:prstGeom>
-          <a:noFill/>
-          <a:ln/>
-        </p:spPr>
-        <p:txBody>
-          <a:bodyPr wrap="square" lIns="0" tIns="0" rIns="0" bIns="0" rtlCol="0" anchor="ctr"/>
-          <a:lstStyle/>
-          <a:p>
-            <a:pPr algn="ctr" indent="0" marL="0">
-              <a:buNone/>
-            </a:pPr>
-            <a:r>
-              <a:rPr lang="en-US" sz="1300" b="1" dirty="0">
-                <a:solidFill>
-                  <a:srgbClr val="9A948A"/>
-                </a:solidFill>
-                <a:latin typeface="Arial" pitchFamily="34" charset="0"/>
-                <a:ea typeface="Arial" pitchFamily="34" charset="-122"/>
-                <a:cs typeface="Arial" pitchFamily="34" charset="-120"/>
-              </a:rPr>
-              <a:t>›</a:t>
+              <a:t>3</a:t>
             </a:r>
             <a:endParaRPr lang="en-US" sz="1300" dirty="0"/>
           </a:p>
@@ -7948,14 +8032,53 @@
       </p:sp>
       <p:sp>
         <p:nvSpPr>
-          <p:cNvPr id="33" name="Shape 31"/>
-          <p:cNvSpPr/>
-          <p:nvPr/>
-        </p:nvSpPr>
-        <p:spPr>
-          <a:xfrm>
-            <a:off x="9791395" y="3630168"/>
-            <a:ext cx="1203350" cy="347472"/>
+          <p:cNvPr id="36" name="Text 34"/>
+          <p:cNvSpPr/>
+          <p:nvPr/>
+        </p:nvSpPr>
+        <p:spPr>
+          <a:xfrm>
+            <a:off x="1371600" y="5166360"/>
+            <a:ext cx="3200400" cy="420624"/>
+          </a:xfrm>
+          <a:prstGeom prst="rect">
+            <a:avLst/>
+          </a:prstGeom>
+          <a:noFill/>
+          <a:ln/>
+        </p:spPr>
+        <p:txBody>
+          <a:bodyPr wrap="square" lIns="0" tIns="0" rIns="0" bIns="0" rtlCol="0" anchor="ctr"/>
+          <a:lstStyle/>
+          <a:p>
+            <a:pPr indent="0" marL="0">
+              <a:buNone/>
+            </a:pPr>
+            <a:r>
+              <a:rPr lang="en-US" sz="1600" b="1" dirty="0">
+                <a:solidFill>
+                  <a:srgbClr val="F4F1EA"/>
+                </a:solidFill>
+                <a:latin typeface="Arial" pitchFamily="34" charset="0"/>
+                <a:ea typeface="Arial" pitchFamily="34" charset="-122"/>
+                <a:cs typeface="Arial" pitchFamily="34" charset="-120"/>
+              </a:rPr>
+              <a:t>Grinnell Glacier</a:t>
+            </a:r>
+            <a:endParaRPr lang="en-US" sz="1600" dirty="0"/>
+          </a:p>
+        </p:txBody>
+      </p:sp>
+      <p:sp>
+        <p:nvSpPr>
+          <p:cNvPr id="37" name="Shape 35"/>
+          <p:cNvSpPr/>
+          <p:nvPr/>
+        </p:nvSpPr>
+        <p:spPr>
+          <a:xfrm>
+            <a:off x="4663440" y="5202936"/>
+            <a:ext cx="640080" cy="347472"/>
           </a:xfrm>
           <a:prstGeom prst="roundRect">
             <a:avLst>
@@ -7963,215 +8086,14 @@
             </a:avLst>
           </a:prstGeom>
           <a:solidFill>
-            <a:srgbClr val="3D6EA5"/>
+            <a:srgbClr val="6E7B52"/>
           </a:solidFill>
           <a:ln/>
         </p:spPr>
       </p:sp>
       <p:sp>
         <p:nvSpPr>
-          <p:cNvPr id="34" name="Text 32"/>
-          <p:cNvSpPr/>
-          <p:nvPr/>
-        </p:nvSpPr>
-        <p:spPr>
-          <a:xfrm>
-            <a:off x="9791395" y="3630168"/>
-            <a:ext cx="1203350" cy="347472"/>
-          </a:xfrm>
-          <a:prstGeom prst="rect">
-            <a:avLst/>
-          </a:prstGeom>
-          <a:noFill/>
-          <a:ln/>
-        </p:spPr>
-        <p:txBody>
-          <a:bodyPr wrap="square" lIns="0" tIns="0" rIns="0" bIns="0" rtlCol="0" anchor="ctr"/>
-          <a:lstStyle/>
-          <a:p>
-            <a:pPr algn="ctr" indent="0" marL="0">
-              <a:buNone/>
-            </a:pPr>
-            <a:r>
-              <a:rPr lang="en-US" sz="1000" b="1" dirty="0">
-                <a:solidFill>
-                  <a:srgbClr val="FFFFFF"/>
-                </a:solidFill>
-                <a:latin typeface="Arial" pitchFamily="34" charset="0"/>
-                <a:ea typeface="Arial" pitchFamily="34" charset="-122"/>
-                <a:cs typeface="Arial" pitchFamily="34" charset="-120"/>
-              </a:rPr>
-              <a:t>Shuttle back</a:t>
-            </a:r>
-            <a:endParaRPr lang="en-US" sz="1000" dirty="0"/>
-          </a:p>
-        </p:txBody>
-      </p:sp>
-      <p:sp>
-        <p:nvSpPr>
-          <p:cNvPr id="35" name="Text 33"/>
-          <p:cNvSpPr/>
-          <p:nvPr/>
-        </p:nvSpPr>
-        <p:spPr>
-          <a:xfrm>
-            <a:off x="1371600" y="4105656"/>
-            <a:ext cx="9997135" cy="512064"/>
-          </a:xfrm>
-          <a:prstGeom prst="rect">
-            <a:avLst/>
-          </a:prstGeom>
-          <a:noFill/>
-          <a:ln/>
-        </p:spPr>
-        <p:txBody>
-          <a:bodyPr wrap="square" lIns="0" tIns="0" rIns="0" bIns="0" rtlCol="0" anchor="t"/>
-          <a:lstStyle/>
-          <a:p>
-            <a:pPr indent="0" marL="0">
-              <a:lnSpc>
-                <a:spcPts val="1500"/>
-              </a:lnSpc>
-              <a:buNone/>
-            </a:pPr>
-            <a:r>
-              <a:rPr lang="en-US" sz="1150" dirty="0">
-                <a:solidFill>
-                  <a:srgbClr val="A9A296"/>
-                </a:solidFill>
-                <a:latin typeface="Arial" pitchFamily="34" charset="0"/>
-                <a:ea typeface="Arial" pitchFamily="34" charset="-122"/>
-                <a:cs typeface="Arial" pitchFamily="34" charset="-120"/>
-              </a:rPr>
-              <a:t>Transfer at Avalanche both directions. We should be long gone by then, but the last bus out of The Loop is 7:30 pm — the summit group has to be down before it goes.</a:t>
-            </a:r>
-            <a:endParaRPr lang="en-US" sz="1150" dirty="0"/>
-          </a:p>
-        </p:txBody>
-      </p:sp>
-      <p:sp>
-        <p:nvSpPr>
-          <p:cNvPr id="36" name="Shape 34"/>
-          <p:cNvSpPr/>
-          <p:nvPr/>
-        </p:nvSpPr>
-        <p:spPr>
-          <a:xfrm>
-            <a:off x="640080" y="4928616"/>
-            <a:ext cx="10911535" cy="1426464"/>
-          </a:xfrm>
-          <a:prstGeom prst="roundRect">
-            <a:avLst>
-              <a:gd name="adj" fmla="val 3205"/>
-            </a:avLst>
-          </a:prstGeom>
-          <a:solidFill>
-            <a:srgbClr val="2E2B27"/>
-          </a:solidFill>
-          <a:ln/>
-        </p:spPr>
-      </p:sp>
-      <p:sp>
-        <p:nvSpPr>
-          <p:cNvPr id="37" name="Shape 35"/>
-          <p:cNvSpPr/>
-          <p:nvPr/>
-        </p:nvSpPr>
-        <p:spPr>
-          <a:xfrm>
-            <a:off x="914400" y="5202936"/>
-            <a:ext cx="347472" cy="347472"/>
-          </a:xfrm>
-          <a:prstGeom prst="ellipse">
-            <a:avLst/>
-          </a:prstGeom>
-          <a:solidFill>
-            <a:srgbClr val="E2574C"/>
-          </a:solidFill>
-          <a:ln/>
-        </p:spPr>
-      </p:sp>
-      <p:sp>
-        <p:nvSpPr>
           <p:cNvPr id="38" name="Text 36"/>
-          <p:cNvSpPr/>
-          <p:nvPr/>
-        </p:nvSpPr>
-        <p:spPr>
-          <a:xfrm>
-            <a:off x="914400" y="5202936"/>
-            <a:ext cx="347472" cy="347472"/>
-          </a:xfrm>
-          <a:prstGeom prst="rect">
-            <a:avLst/>
-          </a:prstGeom>
-          <a:noFill/>
-          <a:ln/>
-        </p:spPr>
-        <p:txBody>
-          <a:bodyPr wrap="square" lIns="0" tIns="0" rIns="0" bIns="0" rtlCol="0" anchor="ctr"/>
-          <a:lstStyle/>
-          <a:p>
-            <a:pPr algn="ctr" indent="0" marL="0">
-              <a:buNone/>
-            </a:pPr>
-            <a:r>
-              <a:rPr lang="en-US" sz="1300" b="1" dirty="0">
-                <a:solidFill>
-                  <a:srgbClr val="FFFFFF"/>
-                </a:solidFill>
-                <a:latin typeface="Arial" pitchFamily="34" charset="0"/>
-                <a:ea typeface="Arial" pitchFamily="34" charset="-122"/>
-                <a:cs typeface="Arial" pitchFamily="34" charset="-120"/>
-              </a:rPr>
-              <a:t>3</a:t>
-            </a:r>
-            <a:endParaRPr lang="en-US" sz="1300" dirty="0"/>
-          </a:p>
-        </p:txBody>
-      </p:sp>
-      <p:sp>
-        <p:nvSpPr>
-          <p:cNvPr id="39" name="Text 37"/>
-          <p:cNvSpPr/>
-          <p:nvPr/>
-        </p:nvSpPr>
-        <p:spPr>
-          <a:xfrm>
-            <a:off x="1371600" y="5166360"/>
-            <a:ext cx="3200400" cy="420624"/>
-          </a:xfrm>
-          <a:prstGeom prst="rect">
-            <a:avLst/>
-          </a:prstGeom>
-          <a:noFill/>
-          <a:ln/>
-        </p:spPr>
-        <p:txBody>
-          <a:bodyPr wrap="square" lIns="0" tIns="0" rIns="0" bIns="0" rtlCol="0" anchor="ctr"/>
-          <a:lstStyle/>
-          <a:p>
-            <a:pPr indent="0" marL="0">
-              <a:buNone/>
-            </a:pPr>
-            <a:r>
-              <a:rPr lang="en-US" sz="1600" b="1" dirty="0">
-                <a:solidFill>
-                  <a:srgbClr val="F4F1EA"/>
-                </a:solidFill>
-                <a:latin typeface="Arial" pitchFamily="34" charset="0"/>
-                <a:ea typeface="Arial" pitchFamily="34" charset="-122"/>
-                <a:cs typeface="Arial" pitchFamily="34" charset="-120"/>
-              </a:rPr>
-              <a:t>Grinnell Glacier</a:t>
-            </a:r>
-            <a:endParaRPr lang="en-US" sz="1600" dirty="0"/>
-          </a:p>
-        </p:txBody>
-      </p:sp>
-      <p:sp>
-        <p:nvSpPr>
-          <p:cNvPr id="40" name="Shape 38"/>
           <p:cNvSpPr/>
           <p:nvPr/>
         </p:nvSpPr>
@@ -8179,6 +8101,84 @@
           <a:xfrm>
             <a:off x="4663440" y="5202936"/>
             <a:ext cx="640080" cy="347472"/>
+          </a:xfrm>
+          <a:prstGeom prst="rect">
+            <a:avLst/>
+          </a:prstGeom>
+          <a:noFill/>
+          <a:ln/>
+        </p:spPr>
+        <p:txBody>
+          <a:bodyPr wrap="square" lIns="0" tIns="0" rIns="0" bIns="0" rtlCol="0" anchor="ctr"/>
+          <a:lstStyle/>
+          <a:p>
+            <a:pPr algn="ctr" indent="0" marL="0">
+              <a:buNone/>
+            </a:pPr>
+            <a:r>
+              <a:rPr lang="en-US" sz="1000" b="1" dirty="0">
+                <a:solidFill>
+                  <a:srgbClr val="FFFFFF"/>
+                </a:solidFill>
+                <a:latin typeface="Arial" pitchFamily="34" charset="0"/>
+                <a:ea typeface="Arial" pitchFamily="34" charset="-122"/>
+                <a:cs typeface="Arial" pitchFamily="34" charset="-120"/>
+              </a:rPr>
+              <a:t>Drive</a:t>
+            </a:r>
+            <a:endParaRPr lang="en-US" sz="1000" dirty="0"/>
+          </a:p>
+        </p:txBody>
+      </p:sp>
+      <p:sp>
+        <p:nvSpPr>
+          <p:cNvPr id="39" name="Text 37"/>
+          <p:cNvSpPr/>
+          <p:nvPr/>
+        </p:nvSpPr>
+        <p:spPr>
+          <a:xfrm>
+            <a:off x="5303520" y="5202936"/>
+            <a:ext cx="219456" cy="347472"/>
+          </a:xfrm>
+          <a:prstGeom prst="rect">
+            <a:avLst/>
+          </a:prstGeom>
+          <a:noFill/>
+          <a:ln/>
+        </p:spPr>
+        <p:txBody>
+          <a:bodyPr wrap="square" lIns="0" tIns="0" rIns="0" bIns="0" rtlCol="0" anchor="ctr"/>
+          <a:lstStyle/>
+          <a:p>
+            <a:pPr algn="ctr" indent="0" marL="0">
+              <a:buNone/>
+            </a:pPr>
+            <a:r>
+              <a:rPr lang="en-US" sz="1300" b="1" dirty="0">
+                <a:solidFill>
+                  <a:srgbClr val="9A948A"/>
+                </a:solidFill>
+                <a:latin typeface="Arial" pitchFamily="34" charset="0"/>
+                <a:ea typeface="Arial" pitchFamily="34" charset="-122"/>
+                <a:cs typeface="Arial" pitchFamily="34" charset="-120"/>
+              </a:rPr>
+              <a:t>›</a:t>
+            </a:r>
+            <a:endParaRPr lang="en-US" sz="1300" dirty="0"/>
+          </a:p>
+        </p:txBody>
+      </p:sp>
+      <p:sp>
+        <p:nvSpPr>
+          <p:cNvPr id="40" name="Shape 38"/>
+          <p:cNvSpPr/>
+          <p:nvPr/>
+        </p:nvSpPr>
+        <p:spPr>
+          <a:xfrm>
+            <a:off x="5522976" y="5202936"/>
+            <a:ext cx="1444752" cy="347472"/>
           </a:xfrm>
           <a:prstGeom prst="roundRect">
             <a:avLst>
@@ -8186,7 +8186,7 @@
             </a:avLst>
           </a:prstGeom>
           <a:solidFill>
-            <a:srgbClr val="6E7B52"/>
+            <a:srgbClr val="E2574C"/>
           </a:solidFill>
           <a:ln/>
         </p:spPr>
@@ -8194,84 +8194,6 @@
       <p:sp>
         <p:nvSpPr>
           <p:cNvPr id="41" name="Text 39"/>
-          <p:cNvSpPr/>
-          <p:nvPr/>
-        </p:nvSpPr>
-        <p:spPr>
-          <a:xfrm>
-            <a:off x="4663440" y="5202936"/>
-            <a:ext cx="640080" cy="347472"/>
-          </a:xfrm>
-          <a:prstGeom prst="rect">
-            <a:avLst/>
-          </a:prstGeom>
-          <a:noFill/>
-          <a:ln/>
-        </p:spPr>
-        <p:txBody>
-          <a:bodyPr wrap="square" lIns="0" tIns="0" rIns="0" bIns="0" rtlCol="0" anchor="ctr"/>
-          <a:lstStyle/>
-          <a:p>
-            <a:pPr algn="ctr" indent="0" marL="0">
-              <a:buNone/>
-            </a:pPr>
-            <a:r>
-              <a:rPr lang="en-US" sz="1000" b="1" dirty="0">
-                <a:solidFill>
-                  <a:srgbClr val="FFFFFF"/>
-                </a:solidFill>
-                <a:latin typeface="Arial" pitchFamily="34" charset="0"/>
-                <a:ea typeface="Arial" pitchFamily="34" charset="-122"/>
-                <a:cs typeface="Arial" pitchFamily="34" charset="-120"/>
-              </a:rPr>
-              <a:t>Drive</a:t>
-            </a:r>
-            <a:endParaRPr lang="en-US" sz="1000" dirty="0"/>
-          </a:p>
-        </p:txBody>
-      </p:sp>
-      <p:sp>
-        <p:nvSpPr>
-          <p:cNvPr id="42" name="Text 40"/>
-          <p:cNvSpPr/>
-          <p:nvPr/>
-        </p:nvSpPr>
-        <p:spPr>
-          <a:xfrm>
-            <a:off x="5303520" y="5202936"/>
-            <a:ext cx="219456" cy="347472"/>
-          </a:xfrm>
-          <a:prstGeom prst="rect">
-            <a:avLst/>
-          </a:prstGeom>
-          <a:noFill/>
-          <a:ln/>
-        </p:spPr>
-        <p:txBody>
-          <a:bodyPr wrap="square" lIns="0" tIns="0" rIns="0" bIns="0" rtlCol="0" anchor="ctr"/>
-          <a:lstStyle/>
-          <a:p>
-            <a:pPr algn="ctr" indent="0" marL="0">
-              <a:buNone/>
-            </a:pPr>
-            <a:r>
-              <a:rPr lang="en-US" sz="1300" b="1" dirty="0">
-                <a:solidFill>
-                  <a:srgbClr val="9A948A"/>
-                </a:solidFill>
-                <a:latin typeface="Arial" pitchFamily="34" charset="0"/>
-                <a:ea typeface="Arial" pitchFamily="34" charset="-122"/>
-                <a:cs typeface="Arial" pitchFamily="34" charset="-120"/>
-              </a:rPr>
-              <a:t>›</a:t>
-            </a:r>
-            <a:endParaRPr lang="en-US" sz="1300" dirty="0"/>
-          </a:p>
-        </p:txBody>
-      </p:sp>
-      <p:sp>
-        <p:nvSpPr>
-          <p:cNvPr id="43" name="Shape 41"/>
           <p:cNvSpPr/>
           <p:nvPr/>
         </p:nvSpPr>
@@ -8279,6 +8201,84 @@
           <a:xfrm>
             <a:off x="5522976" y="5202936"/>
             <a:ext cx="1444752" cy="347472"/>
+          </a:xfrm>
+          <a:prstGeom prst="rect">
+            <a:avLst/>
+          </a:prstGeom>
+          <a:noFill/>
+          <a:ln/>
+        </p:spPr>
+        <p:txBody>
+          <a:bodyPr wrap="square" lIns="0" tIns="0" rIns="0" bIns="0" rtlCol="0" anchor="ctr"/>
+          <a:lstStyle/>
+          <a:p>
+            <a:pPr algn="ctr" indent="0" marL="0">
+              <a:buNone/>
+            </a:pPr>
+            <a:r>
+              <a:rPr lang="en-US" sz="1000" b="1" dirty="0">
+                <a:solidFill>
+                  <a:srgbClr val="FFFFFF"/>
+                </a:solidFill>
+                <a:latin typeface="Arial" pitchFamily="34" charset="0"/>
+                <a:ea typeface="Arial" pitchFamily="34" charset="-122"/>
+                <a:cs typeface="Arial" pitchFamily="34" charset="-120"/>
+              </a:rPr>
+              <a:t>Hike out &amp; back</a:t>
+            </a:r>
+            <a:endParaRPr lang="en-US" sz="1000" dirty="0"/>
+          </a:p>
+        </p:txBody>
+      </p:sp>
+      <p:sp>
+        <p:nvSpPr>
+          <p:cNvPr id="42" name="Text 40"/>
+          <p:cNvSpPr/>
+          <p:nvPr/>
+        </p:nvSpPr>
+        <p:spPr>
+          <a:xfrm>
+            <a:off x="6967728" y="5202936"/>
+            <a:ext cx="219456" cy="347472"/>
+          </a:xfrm>
+          <a:prstGeom prst="rect">
+            <a:avLst/>
+          </a:prstGeom>
+          <a:noFill/>
+          <a:ln/>
+        </p:spPr>
+        <p:txBody>
+          <a:bodyPr wrap="square" lIns="0" tIns="0" rIns="0" bIns="0" rtlCol="0" anchor="ctr"/>
+          <a:lstStyle/>
+          <a:p>
+            <a:pPr algn="ctr" indent="0" marL="0">
+              <a:buNone/>
+            </a:pPr>
+            <a:r>
+              <a:rPr lang="en-US" sz="1300" b="1" dirty="0">
+                <a:solidFill>
+                  <a:srgbClr val="9A948A"/>
+                </a:solidFill>
+                <a:latin typeface="Arial" pitchFamily="34" charset="0"/>
+                <a:ea typeface="Arial" pitchFamily="34" charset="-122"/>
+                <a:cs typeface="Arial" pitchFamily="34" charset="-120"/>
+              </a:rPr>
+              <a:t>›</a:t>
+            </a:r>
+            <a:endParaRPr lang="en-US" sz="1300" dirty="0"/>
+          </a:p>
+        </p:txBody>
+      </p:sp>
+      <p:sp>
+        <p:nvSpPr>
+          <p:cNvPr id="43" name="Shape 41"/>
+          <p:cNvSpPr/>
+          <p:nvPr/>
+        </p:nvSpPr>
+        <p:spPr>
+          <a:xfrm>
+            <a:off x="7187184" y="5202936"/>
+            <a:ext cx="640080" cy="347472"/>
           </a:xfrm>
           <a:prstGeom prst="roundRect">
             <a:avLst>
@@ -8286,7 +8286,7 @@
             </a:avLst>
           </a:prstGeom>
           <a:solidFill>
-            <a:srgbClr val="E2574C"/>
+            <a:srgbClr val="6E7B52"/>
           </a:solidFill>
           <a:ln/>
         </p:spPr>
@@ -8294,84 +8294,6 @@
       <p:sp>
         <p:nvSpPr>
           <p:cNvPr id="44" name="Text 42"/>
-          <p:cNvSpPr/>
-          <p:nvPr/>
-        </p:nvSpPr>
-        <p:spPr>
-          <a:xfrm>
-            <a:off x="5522976" y="5202936"/>
-            <a:ext cx="1444752" cy="347472"/>
-          </a:xfrm>
-          <a:prstGeom prst="rect">
-            <a:avLst/>
-          </a:prstGeom>
-          <a:noFill/>
-          <a:ln/>
-        </p:spPr>
-        <p:txBody>
-          <a:bodyPr wrap="square" lIns="0" tIns="0" rIns="0" bIns="0" rtlCol="0" anchor="ctr"/>
-          <a:lstStyle/>
-          <a:p>
-            <a:pPr algn="ctr" indent="0" marL="0">
-              <a:buNone/>
-            </a:pPr>
-            <a:r>
-              <a:rPr lang="en-US" sz="1000" b="1" dirty="0">
-                <a:solidFill>
-                  <a:srgbClr val="FFFFFF"/>
-                </a:solidFill>
-                <a:latin typeface="Arial" pitchFamily="34" charset="0"/>
-                <a:ea typeface="Arial" pitchFamily="34" charset="-122"/>
-                <a:cs typeface="Arial" pitchFamily="34" charset="-120"/>
-              </a:rPr>
-              <a:t>Hike out &amp; back</a:t>
-            </a:r>
-            <a:endParaRPr lang="en-US" sz="1000" dirty="0"/>
-          </a:p>
-        </p:txBody>
-      </p:sp>
-      <p:sp>
-        <p:nvSpPr>
-          <p:cNvPr id="45" name="Text 43"/>
-          <p:cNvSpPr/>
-          <p:nvPr/>
-        </p:nvSpPr>
-        <p:spPr>
-          <a:xfrm>
-            <a:off x="6967728" y="5202936"/>
-            <a:ext cx="219456" cy="347472"/>
-          </a:xfrm>
-          <a:prstGeom prst="rect">
-            <a:avLst/>
-          </a:prstGeom>
-          <a:noFill/>
-          <a:ln/>
-        </p:spPr>
-        <p:txBody>
-          <a:bodyPr wrap="square" lIns="0" tIns="0" rIns="0" bIns="0" rtlCol="0" anchor="ctr"/>
-          <a:lstStyle/>
-          <a:p>
-            <a:pPr algn="ctr" indent="0" marL="0">
-              <a:buNone/>
-            </a:pPr>
-            <a:r>
-              <a:rPr lang="en-US" sz="1300" b="1" dirty="0">
-                <a:solidFill>
-                  <a:srgbClr val="9A948A"/>
-                </a:solidFill>
-                <a:latin typeface="Arial" pitchFamily="34" charset="0"/>
-                <a:ea typeface="Arial" pitchFamily="34" charset="-122"/>
-                <a:cs typeface="Arial" pitchFamily="34" charset="-120"/>
-              </a:rPr>
-              <a:t>›</a:t>
-            </a:r>
-            <a:endParaRPr lang="en-US" sz="1300" dirty="0"/>
-          </a:p>
-        </p:txBody>
-      </p:sp>
-      <p:sp>
-        <p:nvSpPr>
-          <p:cNvPr id="46" name="Shape 44"/>
           <p:cNvSpPr/>
           <p:nvPr/>
         </p:nvSpPr>
@@ -8380,28 +8302,6 @@
             <a:off x="7187184" y="5202936"/>
             <a:ext cx="640080" cy="347472"/>
           </a:xfrm>
-          <a:prstGeom prst="roundRect">
-            <a:avLst>
-              <a:gd name="adj" fmla="val 50000"/>
-            </a:avLst>
-          </a:prstGeom>
-          <a:solidFill>
-            <a:srgbClr val="6E7B52"/>
-          </a:solidFill>
-          <a:ln/>
-        </p:spPr>
-      </p:sp>
-      <p:sp>
-        <p:nvSpPr>
-          <p:cNvPr id="47" name="Text 45"/>
-          <p:cNvSpPr/>
-          <p:nvPr/>
-        </p:nvSpPr>
-        <p:spPr>
-          <a:xfrm>
-            <a:off x="7187184" y="5202936"/>
-            <a:ext cx="640080" cy="347472"/>
-          </a:xfrm>
           <a:prstGeom prst="rect">
             <a:avLst/>
           </a:prstGeom>
@@ -8432,7 +8332,7 @@
       </p:sp>
       <p:sp>
         <p:nvSpPr>
-          <p:cNvPr id="48" name="Text 46"/>
+          <p:cNvPr id="45" name="Text 43"/>
           <p:cNvSpPr/>
           <p:nvPr/>
         </p:nvSpPr>

</xml_diff>